<commit_message>
Week 4 Thursday: the cold reads' fixes in the three decks
Every term the ticket uses is opened where it first appears, the toy funnel is counted in one
unit, the comparators sit on the step blamed, the tracking check is the order records, the cost is
a range in order value, the sale is judged on payback, and the AI variant reads week four two
months after launch. The Kahoot slide now matches the quiz.

Co-Authored-By: Claude Opus 5.5 <noreply@anthropic.com>
Claude-Session: https://claude.ai/code/session_01NPLds1PXr7nZqxdmBPv5HF
</commit_message>
<xml_diff>
--- a/content/W04/D4/slides/C2_W04_D04_fallback_STUDENT.pptx
+++ b/content/W04/D4/slides/C2_W04_D04_fallback_STUDENT.pptx
@@ -5458,7 +5458,7 @@
                 </a:solidFill>
                 <a:latin typeface="Calibri"/>
               </a:rPr>
-              <a:t>Zomato's shareholder letter of 19 May 2023 (checked 12 October 2026) says Gold reached 1.8 million members in Q4 FY23, its members' orders were about 30 percent of food delivery GOV in March 2023, and their order frequency rose about 60 percent after joining. The number describes members; it does not show what Gold caused.</a:t>
+              <a:t>Zomato's shareholder letter of 19 May 2023 (checked 12 October 2026) says Gold reached 1.8 million members in Q4 FY23 (January to March 2023), its members' orders were about 30 percent of food delivery GOV, gross order value, the value of all orders placed, in March 2023, and their order frequency rose about 60 percent after joining. The number describes members; it does not show what Gold caused.</a:t>
             </a:r>
           </a:p>
         </p:txBody>
@@ -6074,9 +6074,9 @@
                 <a:tableStyleId>{2D5ABB26-0587-4C30-8999-92F81FD0307C}</a:tableStyleId>
               </a:tblPr>
               <a:tblGrid>
-                <a:gridCol w="4494839"/>
-                <a:gridCol w="3520966"/>
-                <a:gridCol w="3115185"/>
+                <a:gridCol w="4542873"/>
+                <a:gridCol w="3495480"/>
+                <a:gridCol w="3092637"/>
               </a:tblGrid>
               <a:tr h="369824">
                 <a:tc>
@@ -6295,7 +6295,7 @@
                           </a:solidFill>
                           <a:latin typeface="Calibri"/>
                         </a:rPr>
-                        <a:t>A holdout: Gold offered to some, withheld from others</a:t>
+                        <a:t>A hold-out: Gold offered to some, withheld from others</a:t>
                       </a:r>
                     </a:p>
                   </a:txBody>
@@ -7522,7 +7522,7 @@
         </p:nvGraphicFramePr>
         <p:xfrm>
           <a:off x="530352" y="1956816"/>
-          <a:ext cx="11130989" cy="2574544"/>
+          <a:ext cx="11130989" cy="3299968"/>
         </p:xfrm>
         <a:graphic>
           <a:graphicData uri="http://schemas.openxmlformats.org/drawingml/2006/table">
@@ -7592,7 +7592,7 @@
                           </a:solidFill>
                           <a:latin typeface="Calibri"/>
                         </a:rPr>
-                        <a:t>A hire-grade answer</a:t>
+                        <a:t>A hire-grade answer, one that gets the job</a:t>
                       </a:r>
                     </a:p>
                   </a:txBody>
@@ -7728,7 +7728,7 @@
                           </a:solidFill>
                           <a:latin typeface="Calibri"/>
                         </a:rPr>
-                        <a:t>Checkout start to order, 72.5 to 55, members on Android only, from the release week</a:t>
+                        <a:t>Checkout start to order, per session, 72.5 to 55, members on Android only, from the release week</a:t>
                       </a:r>
                     </a:p>
                   </a:txBody>
@@ -7739,7 +7739,7 @@
                   </a:tcPr>
                 </a:tc>
               </a:tr>
-              <a:tr h="369824">
+              <a:tr h="853440">
                 <a:tc>
                   <a:txBody>
                     <a:bodyPr/>
@@ -7796,7 +7796,7 @@
                           </a:solidFill>
                           <a:latin typeface="Calibri"/>
                         </a:rPr>
-                        <a:t>iOS members 57 to 56; non-members on Android 52 to 51</a:t>
+                        <a:t>On the same step, iOS members 71 to 70 and non-members on Android 65 to 64; members who joined before August, iOS 68.6 to 69.3</a:t>
                       </a:r>
                     </a:p>
                   </a:txBody>
@@ -7807,7 +7807,7 @@
                   </a:tcPr>
                 </a:tc>
               </a:tr>
-              <a:tr h="611632">
+              <a:tr h="853440">
                 <a:tc>
                   <a:txBody>
                     <a:bodyPr/>
@@ -7864,7 +7864,7 @@
                           </a:solidFill>
                           <a:latin typeface="Calibri"/>
                         </a:rPr>
-                        <a:t>"If the event the release renamed is mapped wrong, I'd rerun it on your mapping."</a:t>
+                        <a:t>"If the order records showed orders holding while the event log fell, or if members who failed came back and ordered later, I'd withdraw it."</a:t>
                       </a:r>
                     </a:p>
                   </a:txBody>
@@ -9202,7 +9202,7 @@
                 </a:solidFill>
                 <a:latin typeface="Calibri"/>
               </a:rPr>
-              <a:t>unprofitable Instamart users, over three quarters to Q1 FY27</a:t>
+              <a:t>Instamart users who cost Swiggy money, let go over the three quarters to Q1 FY27</a:t>
             </a:r>
           </a:p>
         </p:txBody>
@@ -9351,7 +9351,7 @@
                 </a:solidFill>
                 <a:latin typeface="Calibri"/>
               </a:rPr>
-              <a:t>one-month retention of the transacting base, Q1 FY26 to Q1 FY27</a:t>
+              <a:t>Instamart's one-month retention of the users who ordered, Q1 FY26 to Q1 FY27</a:t>
             </a:r>
           </a:p>
         </p:txBody>
@@ -9465,7 +9465,7 @@
                 </a:solidFill>
                 <a:latin typeface="Calibri"/>
               </a:rPr>
-              <a:t>SPEND AT Q6</a:t>
+              <a:t>SPEND IN THE SIXTH QUARTER</a:t>
             </a:r>
           </a:p>
         </p:txBody>
@@ -9500,7 +9500,7 @@
                 </a:solidFill>
                 <a:latin typeface="Calibri"/>
               </a:rPr>
-              <a:t>the Q4 FY24 cohort's spend in its sixth quarter against its first</a:t>
+              <a:t>the cohort that joined in Q4 FY24, against what it spent in the quarter it joined</a:t>
             </a:r>
           </a:p>
         </p:txBody>
@@ -9558,7 +9558,7 @@
         <p:spPr>
           <a:xfrm>
             <a:off x="530352" y="3419856"/>
-            <a:ext cx="11130991" cy="1048512"/>
+            <a:ext cx="11130991" cy="1601216"/>
           </a:xfrm>
           <a:prstGeom prst="rect">
             <a:avLst/>
@@ -9583,7 +9583,7 @@
                 </a:solidFill>
                 <a:latin typeface="Calibri"/>
               </a:rPr>
-              <a:t>Swiggy says it used cohort-level levers (minimum order thresholds, free deliveries, new-user coupons) and weaned away users with low expected lifetime value. Sources: Swiggy's Q1 FY27 and Q2 FY26 shareholder letters, each checked 12 October 2026.</a:t>
+              <a:t>Swiggy says it used offers aimed at chosen groups of users (minimum order values, free deliveries, new-user coupons) and "weaned away certain users ... with low potential Lifetime values", the value a user is expected to bring over all the time she stays, by withdrawing the offers that kept them. India's financial year runs April to March, so Q1 FY27 is April to June 2026 and Q4 FY24 is January to March 2024. Sources: Swiggy's Q1 FY27 and Q2 FY26 shareholder letters, each checked 12 October 2026.</a:t>
             </a:r>
           </a:p>
         </p:txBody>
@@ -11211,7 +11211,7 @@
         <p:spPr>
           <a:xfrm>
             <a:off x="530352" y="4374832"/>
-            <a:ext cx="11130991" cy="1048512"/>
+            <a:ext cx="11130991" cy="1324864"/>
           </a:xfrm>
           <a:prstGeom prst="rect">
             <a:avLst/>
@@ -11236,7 +11236,7 @@
                 </a:solidFill>
                 <a:latin typeface="Calibri"/>
               </a:rPr>
-              <a:t>A cohort chart without its denominator is a shape. Swiggy's table is indexed to its Q4 FY24 cohort's first quarter, and calls the groups "retained user cohorts": the first thing to ask is who stays in the count.</a:t>
+              <a:t>A cohort chart without its denominator is a shape. Swiggy's table compares each cohort's spend with the quarter it joined and calls the groups "retained user cohorts", and it states no denominator: the first thing to ask is who stays in the count. Removing users in one quarter lifts that quarter's cells and every later one, with nobody's behaviour changing.</a:t>
             </a:r>
           </a:p>
         </p:txBody>
@@ -12408,7 +12408,7 @@
         <p:spPr>
           <a:xfrm>
             <a:off x="530352" y="1956816"/>
-            <a:ext cx="11130991" cy="1467104"/>
+            <a:ext cx="11130991" cy="2224531"/>
           </a:xfrm>
           <a:prstGeom prst="roundRect">
             <a:avLst>
@@ -12592,7 +12592,7 @@
         <p:spPr>
           <a:xfrm>
             <a:off x="804671" y="2286000"/>
-            <a:ext cx="10673791" cy="1064768"/>
+            <a:ext cx="10673791" cy="1822195"/>
           </a:xfrm>
           <a:prstGeom prst="rect">
             <a:avLst/>
@@ -12633,7 +12633,7 @@
                 </a:solidFill>
                 <a:latin typeface="Consolas"/>
               </a:rPr>
-              <a:t>week = lambda t: t.dt.to_period("W-SUN").dt.start_time      # weeks start on Monday</a:t>
+              <a:t>monday = placed["event_ts"].dt.to_period("W-SUN").dt.start_time   # W-SUN: weeks end on Sunday, so each starts on a Monday</a:t>
             </a:r>
           </a:p>
           <a:p>
@@ -12649,7 +12649,7 @@
                 </a:solidFill>
                 <a:latin typeface="Consolas"/>
               </a:rPr>
-              <a:t>orders_week = set(zip(placed["user_id"], week(placed["event_ts"])))</a:t>
+              <a:t>orders_week = set(zip(placed["user_id"], monday))                # user_id in events is the member_id in members</a:t>
             </a:r>
           </a:p>
           <a:p>
@@ -12665,7 +12665,23 @@
                 </a:solidFill>
                 <a:latin typeface="Consolas"/>
               </a:rPr>
-              <a:t># members who joined 3 August to 13 September; week k is the k-th full week after the signup week</a:t>
+              <a:t># a member's signup week starts on the Monday on or before her signup date;</a:t>
+            </a:r>
+          </a:p>
+          <a:p>
+            <a:pPr>
+              <a:spcAft>
+                <a:spcPts val="200"/>
+              </a:spcAft>
+            </a:pPr>
+            <a:r>
+              <a:rPr sz="1400" b="0" i="0">
+                <a:solidFill>
+                  <a:srgbClr val="A9A3D2"/>
+                </a:solidFill>
+                <a:latin typeface="Consolas"/>
+              </a:rPr>
+              <a:t># week k is the week whose Monday is k x 7 days after that one</a:t>
             </a:r>
           </a:p>
         </p:txBody>
@@ -12678,7 +12694,7 @@
         </p:nvSpPr>
         <p:spPr>
           <a:xfrm>
-            <a:off x="530352" y="3588512"/>
+            <a:off x="530352" y="4345939"/>
             <a:ext cx="11130991" cy="1048512"/>
           </a:xfrm>
           <a:prstGeom prst="rect">
@@ -13996,7 +14012,7 @@
         </p:nvGraphicFramePr>
         <p:xfrm>
           <a:off x="530352" y="1956816"/>
-          <a:ext cx="11130990" cy="2332736"/>
+          <a:ext cx="11130991" cy="2332736"/>
         </p:xfrm>
         <a:graphic>
           <a:graphicData uri="http://schemas.openxmlformats.org/drawingml/2006/table">
@@ -14005,8 +14021,8 @@
                 <a:tableStyleId>{2D5ABB26-0587-4C30-8999-92F81FD0307C}</a:tableStyleId>
               </a:tblPr>
               <a:tblGrid>
-                <a:gridCol w="4389567"/>
-                <a:gridCol w="6741423"/>
+                <a:gridCol w="5003138"/>
+                <a:gridCol w="6127853"/>
               </a:tblGrid>
               <a:tr h="369824">
                 <a:tc>
@@ -14205,7 +14221,7 @@
                           </a:solidFill>
                           <a:latin typeface="Calibri"/>
                         </a:rPr>
-                        <a:t>The last month counts</a:t>
+                        <a:t>September, the last month, is whole and counted</a:t>
                       </a:r>
                     </a:p>
                   </a:txBody>
@@ -14227,7 +14243,7 @@
                           </a:solidFill>
                           <a:latin typeface="Calibri"/>
                         </a:rPr>
-                        <a:t>The last week is partial and leaves the table</a:t>
+                        <a:t>The week of 28 September has three days and is left out</a:t>
                       </a:r>
                     </a:p>
                   </a:txBody>

</xml_diff>

<commit_message>
Week 4 Thursday: the cold reads' fixes in the exercises, quiz, take-home, notes, sheet and trainer files
Each set opens its levels and terms on its own page; the toy funnel is counted in sessions; the
fix-first page carries same-step comparators, a cost range in order value and the retries; the Kalpa
call's key now rests on the monsoon cohort holding September's blend up. The take-home shows how to
get a week from two dates and which id joins the tables. The transcript hands over every number the
candidate uses, reads the AI variant two months after launch, and cites each source with its link.
The guesstimate validates trips against DMRC's line-use count. The sheet's second panel carries the
twelve rows.

Co-Authored-By: Claude Opus 5.5 <noreply@anthropic.com>
Claude-Session: https://claude.ai/code/session_01NPLds1PXr7nZqxdmBPv5HF
</commit_message>
<xml_diff>
--- a/content/W04/D4/slides/C2_W04_D04_fallback_STUDENT.pptx
+++ b/content/W04/D4/slides/C2_W04_D04_fallback_STUDENT.pptx
@@ -12629,11 +12629,11 @@
             <a:r>
               <a:rPr sz="1400" b="0" i="0">
                 <a:solidFill>
-                  <a:srgbClr val="E4E1F1"/>
+                  <a:srgbClr val="A9A3D2"/>
                 </a:solidFill>
                 <a:latin typeface="Consolas"/>
               </a:rPr>
-              <a:t>monday = placed["event_ts"].dt.to_period("W-SUN").dt.start_time   # W-SUN: weeks end on Sunday, so each starts on a Monday</a:t>
+              <a:t># W-SUN: weeks end on Sunday, so each week starts on a Monday</a:t>
             </a:r>
           </a:p>
           <a:p>
@@ -12649,7 +12649,7 @@
                 </a:solidFill>
                 <a:latin typeface="Consolas"/>
               </a:rPr>
-              <a:t>orders_week = set(zip(placed["user_id"], monday))                # user_id in events is the member_id in members</a:t>
+              <a:t>monday = placed["event_ts"].dt.to_period("W-SUN").dt.start_time</a:t>
             </a:r>
           </a:p>
           <a:p>
@@ -12665,7 +12665,39 @@
                 </a:solidFill>
                 <a:latin typeface="Consolas"/>
               </a:rPr>
-              <a:t># a member's signup week starts on the Monday on or before her signup date;</a:t>
+              <a:t># user_id in events is the member's member_id in members</a:t>
+            </a:r>
+          </a:p>
+          <a:p>
+            <a:pPr>
+              <a:spcAft>
+                <a:spcPts val="200"/>
+              </a:spcAft>
+            </a:pPr>
+            <a:r>
+              <a:rPr sz="1400" b="0" i="0">
+                <a:solidFill>
+                  <a:srgbClr val="E4E1F1"/>
+                </a:solidFill>
+                <a:latin typeface="Consolas"/>
+              </a:rPr>
+              <a:t>orders_week = set(zip(placed["user_id"], monday))</a:t>
+            </a:r>
+          </a:p>
+          <a:p>
+            <a:pPr>
+              <a:spcAft>
+                <a:spcPts val="200"/>
+              </a:spcAft>
+            </a:pPr>
+            <a:r>
+              <a:rPr sz="1400" b="0" i="0">
+                <a:solidFill>
+                  <a:srgbClr val="A9A3D2"/>
+                </a:solidFill>
+                <a:latin typeface="Consolas"/>
+              </a:rPr>
+              <a:t># her signup week starts on the Monday on or before her signup date;</a:t>
             </a:r>
           </a:p>
           <a:p>

</xml_diff>

<commit_message>
W04 D4: the trainer sheets time the drills inside their chapters, strike tracking at S64, list the departures from the row, and the fallback runs SECTIONs 12 to 15 in 120 minutes
Co-Authored-By: Claude Opus 5.5 <noreply@anthropic.com>
Claude-Session: https://claude.ai/code/session_01TvM13LJMo8DngoahNnqaWr
</commit_message>
<xml_diff>
--- a/content/W04/D4/slides/C2_W04_D04_fallback_STUDENT.pptx
+++ b/content/W04/D4/slides/C2_W04_D04_fallback_STUDENT.pptx
@@ -860,7 +860,7 @@
           <a:lstStyle/>
           <a:p>
             <a:r>
-              <a:t>LIVE, 15 minutes. Pairs score the hire-grade side on the scorecard. The move is Tuesday's: restate,</a:t>
+              <a:t>LIVE, 18 minutes. Pairs read the dispute, then score the hire-grade side on the scorecard. The move is Tuesday's: restate,</a:t>
             </a:r>
           </a:p>
           <a:p>
@@ -945,7 +945,7 @@
           </a:p>
           <a:p>
             <a:r>
-              <a:t>faculty block (tentative) takes them whenever it runs. Then return to the Kahoot if it has not run.</a:t>
+              <a:t>faculty block (tentative) takes them whenever it runs.</a:t>
             </a:r>
           </a:p>
           <a:p>
@@ -4794,7 +4794,7 @@
                 </a:solidFill>
                 <a:latin typeface="Georgia"/>
               </a:rPr>
-              <a:t>07</a:t>
+              <a:t>12</a:t>
             </a:r>
           </a:p>
         </p:txBody>
@@ -5119,7 +5119,7 @@
                 </a:solidFill>
                 <a:latin typeface="Calibri"/>
               </a:rPr>
-              <a:t>Week 4 Day 4: the fallback block</a:t>
+              <a:t>Week 4, Day 4. When can a retention number rise or hold with nobody's behaviour changing?</a:t>
             </a:r>
           </a:p>
         </p:txBody>
@@ -5402,7 +5402,7 @@
       </p:sp>
       <p:pic>
         <p:nvPicPr>
-          <p:cNvPr id="9" name="mermaid diagram" descr="29d30e77a001c4e4.png"/>
+          <p:cNvPr id="9" name="mermaid diagram" descr="344eb795deba6d10.png"/>
           <p:cNvPicPr>
             <a:picLocks noChangeAspect="1"/>
           </p:cNvPicPr>
@@ -5416,8 +5416,8 @@
         </p:blipFill>
         <p:spPr>
           <a:xfrm>
-            <a:off x="2924022" y="1956816"/>
-            <a:ext cx="6343650" cy="2300287"/>
+            <a:off x="530352" y="1940113"/>
+            <a:ext cx="4786326" cy="4001900"/>
           </a:xfrm>
           <a:prstGeom prst="rect">
             <a:avLst/>
@@ -5432,8 +5432,8 @@
         </p:nvSpPr>
         <p:spPr>
           <a:xfrm>
-            <a:off x="530352" y="4403407"/>
-            <a:ext cx="11130991" cy="1324864"/>
+            <a:off x="5761917" y="1956816"/>
+            <a:ext cx="5899425" cy="2430272"/>
           </a:xfrm>
           <a:prstGeom prst="rect">
             <a:avLst/>
@@ -6906,7 +6906,7 @@
                 </a:solidFill>
                 <a:latin typeface="Georgia"/>
               </a:rPr>
-              <a:t>10</a:t>
+              <a:t>15</a:t>
             </a:r>
           </a:p>
         </p:txBody>
@@ -7231,7 +7231,7 @@
                 </a:solidFill>
                 <a:latin typeface="Calibri"/>
               </a:rPr>
-              <a:t>Week 4 Day 4: the fallback block</a:t>
+              <a:t>Week 4, Day 4. When can a retention number rise or hold with nobody's behaviour changing?</a:t>
             </a:r>
           </a:p>
         </p:txBody>
@@ -11180,7 +11180,7 @@
       </p:sp>
       <p:pic>
         <p:nvPicPr>
-          <p:cNvPr id="9" name="mermaid diagram" descr="c88584e5f6a98df8.png"/>
+          <p:cNvPr id="9" name="mermaid diagram" descr="0f77e012ee3316a6.png"/>
           <p:cNvPicPr>
             <a:picLocks noChangeAspect="1"/>
           </p:cNvPicPr>
@@ -11194,8 +11194,8 @@
         </p:blipFill>
         <p:spPr>
           <a:xfrm>
-            <a:off x="1773878" y="1956816"/>
-            <a:ext cx="8643937" cy="2271712"/>
+            <a:off x="2920111" y="1664208"/>
+            <a:ext cx="6351471" cy="3256279"/>
           </a:xfrm>
           <a:prstGeom prst="rect">
             <a:avLst/>
@@ -11210,8 +11210,8 @@
         </p:nvSpPr>
         <p:spPr>
           <a:xfrm>
-            <a:off x="530352" y="4374832"/>
-            <a:ext cx="11130991" cy="1324864"/>
+            <a:off x="530352" y="4966208"/>
+            <a:ext cx="11130991" cy="1233424"/>
           </a:xfrm>
           <a:prstGeom prst="rect">
             <a:avLst/>
@@ -11224,11 +11224,6 @@
           </a:bodyPr>
           <a:lstStyle/>
           <a:p>
-            <a:pPr>
-              <a:spcAft>
-                <a:spcPts val="800"/>
-              </a:spcAft>
-            </a:pPr>
             <a:r>
               <a:rPr sz="1600" b="0" i="0">
                 <a:solidFill>
@@ -11793,7 +11788,7 @@
                 </a:solidFill>
                 <a:latin typeface="Georgia"/>
               </a:rPr>
-              <a:t>08</a:t>
+              <a:t>13</a:t>
             </a:r>
           </a:p>
         </p:txBody>
@@ -12118,7 +12113,7 @@
                 </a:solidFill>
                 <a:latin typeface="Calibri"/>
               </a:rPr>
-              <a:t>Week 4 Day 4: the fallback block</a:t>
+              <a:t>Week 4, Day 4. When can a retention number rise or hold with nobody's behaviour changing?</a:t>
             </a:r>
           </a:p>
         </p:txBody>
@@ -14842,7 +14837,7 @@
                 </a:solidFill>
                 <a:latin typeface="Georgia"/>
               </a:rPr>
-              <a:t>09</a:t>
+              <a:t>14</a:t>
             </a:r>
           </a:p>
         </p:txBody>
@@ -15167,7 +15162,7 @@
                 </a:solidFill>
                 <a:latin typeface="Calibri"/>
               </a:rPr>
-              <a:t>Week 4 Day 4: the fallback block</a:t>
+              <a:t>Week 4, Day 4. When can a retention number rise or hold with nobody's behaviour changing?</a:t>
             </a:r>
           </a:p>
         </p:txBody>

</xml_diff>